<commit_message>
docs: Update presentation, talk track, demo questions for web search
News Clips slide now shows dual-source ingestion (gov scraper + Bing
grounding across 20+ outlets). Talk track updated with new narration.
Demo questions note updated to reference 58 clips from 21 outlets.
Cost updated to ~$125-200/mo. PPTX rebuilt.

Co-Authored-By: Claude Opus 4.6 (1M context) <noreply@anthropic.com>
</commit_message>
<xml_diff>
--- a/docs/html/presentation.pptx
+++ b/docs/html/presentation.pptx
@@ -4087,7 +4087,7 @@
               </a:defRPr>
             </a:pPr>
             <a:r>
-              <a:t>Automatically collects Governor press releases, then lets staff search or browse them instantly.</a:t>
+              <a:t>Monitors 20+ news outlets and Governor press releases, then lets staff search or browse them instantly.</a:t>
             </a:r>
           </a:p>
         </p:txBody>
@@ -4259,7 +4259,7 @@
               </a:defRPr>
             </a:pPr>
             <a:r>
-              <a:t>Scrape</a:t>
+              <a:t>Scrape + Search</a:t>
             </a:r>
           </a:p>
         </p:txBody>
@@ -4295,7 +4295,7 @@
               </a:defRPr>
             </a:pPr>
             <a:r>
-              <a:t>Azure Function fetches governor.nc.gov press releases, extracts clean text with Mozilla Readability</a:t>
+              <a:t>Azure Function scrapes governor.nc.gov AND searches the web via Azure OpenAI + Bing grounding (WRAL, AP, 20+ outlets)</a:t>
             </a:r>
           </a:p>
         </p:txBody>
@@ -14271,7 +14271,7 @@
               </a:defRPr>
             </a:pPr>
             <a:r>
-              <a:t>Scrape governor.nc.gov</a:t>
+              <a:t>Scrape + Web Search</a:t>
             </a:r>
           </a:p>
         </p:txBody>
@@ -14307,11 +14307,11 @@
               </a:defRPr>
             </a:pPr>
             <a:r>
-              <a:t>Fetch press releases</a:t>
+              <a:t>governor.nc.gov +</a:t>
             </a:r>
             <a:br/>
             <a:r>
-              <a:t>extract clean text</a:t>
+              <a:t>Bing grounding (20+ outlets)</a:t>
             </a:r>
           </a:p>
         </p:txBody>

</xml_diff>